<commit_message>
Add delta visualization between cylinders on bank asymmetry slides
Both presentations (NTE200 and 730E) updated with 3-panel charts:
- Top: A-bank / B-bank time series with intra-bank spread shading
  (fill_between max–min cylinders) and dashed bank-avg line
- Middle: per-cylinder Δ bar chart (deviation from bank average),
  annotated with +/−°C values, color-coded red/orange/green/blue
- Bottom: inter-bank delta over time (B_avg − A_avg), fill_between
  colored red/green by sign, mean Δ annotated in stats box
- Stats box updated: Avg / Max / Δ внутри банка

https://claude.ai/code/session_01C99rvSEB9BzW7Q9nbisCyZ
</commit_message>
<xml_diff>
--- a/DML_Анализ_LogFiles_730E.pptx
+++ b/DML_Анализ_LogFiles_730E.pptx
@@ -4315,7 +4315,7 @@
       </p:sp>
       <p:pic>
         <p:nvPicPr>
-          <p:cNvPr id="6" name="Picture 5" descr="tmpw242zu1b.png"/>
+          <p:cNvPr id="6" name="Picture 5" descr="tmptkcfhi6_.png"/>
           <p:cNvPicPr>
             <a:picLocks noChangeAspect="1"/>
           </p:cNvPicPr>
@@ -9119,7 +9119,7 @@
         <p:spPr>
           <a:xfrm>
             <a:off x="180000" y="36000"/>
-            <a:ext cx="11520000" cy="396000"/>
+            <a:ext cx="11520000" cy="360000"/>
           </a:xfrm>
           <a:prstGeom prst="rect">
             <a:avLst/>
@@ -9134,7 +9134,7 @@
           <a:p>
             <a:pPr algn="l"/>
             <a:r>
-              <a:rPr sz="1600" b="1" i="0">
+              <a:rPr sz="1500" b="1" i="0">
                 <a:solidFill>
                   <a:srgbClr val="FFFFFF"/>
                 </a:solidFill>
@@ -9152,8 +9152,8 @@
         </p:nvSpPr>
         <p:spPr>
           <a:xfrm>
-            <a:off x="180000" y="432000"/>
-            <a:ext cx="11520000" cy="234000"/>
+            <a:off x="180000" y="413999"/>
+            <a:ext cx="11520000" cy="251999"/>
           </a:xfrm>
           <a:prstGeom prst="rect">
             <a:avLst/>
@@ -9168,19 +9168,19 @@
           <a:p>
             <a:pPr algn="l"/>
             <a:r>
-              <a:rPr sz="950" b="0" i="0">
+              <a:rPr sz="900" b="0" i="0">
                 <a:solidFill>
                   <a:srgbClr val="667788"/>
                 </a:solidFill>
               </a:rPr>
-              <a:t>А-банк (нечётные, ECM144) — В-банк (чётные, ECM1)  |  Индивидуальные ЕГТ по цилиндрам</a:t>
+              <a:t>Δ внутри банков  |  Δ каждого цилиндра от среднего  |  Межбанковая асимметрия по времени</a:t>
             </a:r>
           </a:p>
         </p:txBody>
       </p:sp>
       <p:pic>
         <p:nvPicPr>
-          <p:cNvPr id="6" name="Picture 5" descr="tmpznsvr3x_.png"/>
+          <p:cNvPr id="6" name="Picture 5" descr="tmps2vhd267.png"/>
           <p:cNvPicPr>
             <a:picLocks noChangeAspect="1"/>
           </p:cNvPicPr>
@@ -9194,8 +9194,8 @@
         </p:blipFill>
         <p:spPr>
           <a:xfrm>
-            <a:off x="108000" y="756000"/>
-            <a:ext cx="11952000" cy="5580000"/>
+            <a:off x="72000" y="737999"/>
+            <a:ext cx="12045600" cy="5598000"/>
           </a:xfrm>
           <a:prstGeom prst="rect">
             <a:avLst/>
@@ -9210,8 +9210,8 @@
         </p:nvSpPr>
         <p:spPr>
           <a:xfrm>
-            <a:off x="0" y="6372000"/>
-            <a:ext cx="12189600" cy="486000"/>
+            <a:off x="0" y="6364800"/>
+            <a:ext cx="12189600" cy="493200"/>
           </a:xfrm>
           <a:prstGeom prst="rect">
             <a:avLst/>
@@ -9255,8 +9255,8 @@
         </p:nvSpPr>
         <p:spPr>
           <a:xfrm>
-            <a:off x="180000" y="6390000"/>
-            <a:ext cx="11700000" cy="450000"/>
+            <a:off x="144000" y="6382800"/>
+            <a:ext cx="11880000" cy="457200"/>
           </a:xfrm>
           <a:prstGeom prst="rect">
             <a:avLst/>
@@ -9271,12 +9271,12 @@
           <a:p>
             <a:pPr algn="l"/>
             <a:r>
-              <a:rPr sz="1000" b="1" i="0">
+              <a:rPr sz="950" b="1" i="0">
                 <a:solidFill>
                   <a:srgbClr val="FF8C42"/>
                 </a:solidFill>
               </a:rPr>
-              <a:t>ВЫВОД: Банки температурно симметричны. Макс. ЕГТ: 554°C — КРИТИЧНО (&gt;500°C).</a:t>
+              <a:t>ВЫВОД: Банки симметричны.  |  Разброс: А=196°C  В=201°C.  |  Цил.16 горячее avg на +21°C</a:t>
             </a:r>
           </a:p>
         </p:txBody>
@@ -9479,7 +9479,7 @@
         <p:spPr>
           <a:xfrm>
             <a:off x="180000" y="36000"/>
-            <a:ext cx="11520000" cy="396000"/>
+            <a:ext cx="11520000" cy="360000"/>
           </a:xfrm>
           <a:prstGeom prst="rect">
             <a:avLst/>
@@ -9494,7 +9494,7 @@
           <a:p>
             <a:pPr algn="l"/>
             <a:r>
-              <a:rPr sz="1600" b="1" i="0">
+              <a:rPr sz="1500" b="1" i="0">
                 <a:solidFill>
                   <a:srgbClr val="FFFFFF"/>
                 </a:solidFill>
@@ -9512,8 +9512,8 @@
         </p:nvSpPr>
         <p:spPr>
           <a:xfrm>
-            <a:off x="180000" y="432000"/>
-            <a:ext cx="11520000" cy="234000"/>
+            <a:off x="180000" y="413999"/>
+            <a:ext cx="11520000" cy="251999"/>
           </a:xfrm>
           <a:prstGeom prst="rect">
             <a:avLst/>
@@ -9528,19 +9528,19 @@
           <a:p>
             <a:pPr algn="l"/>
             <a:r>
-              <a:rPr sz="950" b="0" i="0">
+              <a:rPr sz="900" b="0" i="0">
                 <a:solidFill>
                   <a:srgbClr val="667788"/>
                 </a:solidFill>
               </a:rPr>
-              <a:t>А-банк (нечётные, ECM144) — В-банк (чётные, ECM1)  |  Индивидуальные ЕГТ по цилиндрам</a:t>
+              <a:t>Δ внутри банков  |  Δ каждого цилиндра от среднего  |  Межбанковая асимметрия по времени</a:t>
             </a:r>
           </a:p>
         </p:txBody>
       </p:sp>
       <p:pic>
         <p:nvPicPr>
-          <p:cNvPr id="6" name="Picture 5" descr="tmpk_7kg_bu.png"/>
+          <p:cNvPr id="6" name="Picture 5" descr="tmpenajb2u9.png"/>
           <p:cNvPicPr>
             <a:picLocks noChangeAspect="1"/>
           </p:cNvPicPr>
@@ -9554,8 +9554,8 @@
         </p:blipFill>
         <p:spPr>
           <a:xfrm>
-            <a:off x="108000" y="756000"/>
-            <a:ext cx="11952000" cy="5580000"/>
+            <a:off x="72000" y="737999"/>
+            <a:ext cx="12045600" cy="5598000"/>
           </a:xfrm>
           <a:prstGeom prst="rect">
             <a:avLst/>
@@ -9570,8 +9570,8 @@
         </p:nvSpPr>
         <p:spPr>
           <a:xfrm>
-            <a:off x="0" y="6372000"/>
-            <a:ext cx="12189600" cy="486000"/>
+            <a:off x="0" y="6364800"/>
+            <a:ext cx="12189600" cy="493200"/>
           </a:xfrm>
           <a:prstGeom prst="rect">
             <a:avLst/>
@@ -9615,8 +9615,8 @@
         </p:nvSpPr>
         <p:spPr>
           <a:xfrm>
-            <a:off x="180000" y="6390000"/>
-            <a:ext cx="11700000" cy="450000"/>
+            <a:off x="144000" y="6382800"/>
+            <a:ext cx="11880000" cy="457200"/>
           </a:xfrm>
           <a:prstGeom prst="rect">
             <a:avLst/>
@@ -9631,12 +9631,12 @@
           <a:p>
             <a:pPr algn="l"/>
             <a:r>
-              <a:rPr sz="1000" b="1" i="0">
+              <a:rPr sz="950" b="1" i="0">
                 <a:solidFill>
                   <a:srgbClr val="FF8C42"/>
                 </a:solidFill>
               </a:rPr>
-              <a:t>ВЫВОД: В-банк горячее А-банка на 358°C. Макс. ЕГТ: 590°C — КРИТИЧНО (&gt;500°C).</a:t>
+              <a:t>ВЫВОД: В-банк горячее А-банка на 358°C.  |  Разброс: А=93°C  В=122°C.  |  Цил.9 горячее avg на +52°C</a:t>
             </a:r>
           </a:p>
         </p:txBody>
@@ -9839,7 +9839,7 @@
         <p:spPr>
           <a:xfrm>
             <a:off x="180000" y="36000"/>
-            <a:ext cx="11520000" cy="396000"/>
+            <a:ext cx="11520000" cy="360000"/>
           </a:xfrm>
           <a:prstGeom prst="rect">
             <a:avLst/>
@@ -9854,7 +9854,7 @@
           <a:p>
             <a:pPr algn="l"/>
             <a:r>
-              <a:rPr sz="1600" b="1" i="0">
+              <a:rPr sz="1500" b="1" i="0">
                 <a:solidFill>
                   <a:srgbClr val="FFFFFF"/>
                 </a:solidFill>
@@ -9872,8 +9872,8 @@
         </p:nvSpPr>
         <p:spPr>
           <a:xfrm>
-            <a:off x="180000" y="432000"/>
-            <a:ext cx="11520000" cy="234000"/>
+            <a:off x="180000" y="413999"/>
+            <a:ext cx="11520000" cy="251999"/>
           </a:xfrm>
           <a:prstGeom prst="rect">
             <a:avLst/>
@@ -9888,19 +9888,19 @@
           <a:p>
             <a:pPr algn="l"/>
             <a:r>
-              <a:rPr sz="950" b="0" i="0">
+              <a:rPr sz="900" b="0" i="0">
                 <a:solidFill>
                   <a:srgbClr val="667788"/>
                 </a:solidFill>
               </a:rPr>
-              <a:t>А-банк (нечётные, ECM144) — В-банк (чётные, ECM1)  |  Индивидуальные ЕГТ по цилиндрам</a:t>
+              <a:t>Δ внутри банков  |  Δ каждого цилиндра от среднего  |  Межбанковая асимметрия по времени</a:t>
             </a:r>
           </a:p>
         </p:txBody>
       </p:sp>
       <p:pic>
         <p:nvPicPr>
-          <p:cNvPr id="6" name="Picture 5" descr="tmpzrjlykmi.png"/>
+          <p:cNvPr id="6" name="Picture 5" descr="tmpxnl6uzl3.png"/>
           <p:cNvPicPr>
             <a:picLocks noChangeAspect="1"/>
           </p:cNvPicPr>
@@ -9914,8 +9914,8 @@
         </p:blipFill>
         <p:spPr>
           <a:xfrm>
-            <a:off x="108000" y="756000"/>
-            <a:ext cx="11952000" cy="5580000"/>
+            <a:off x="72000" y="737999"/>
+            <a:ext cx="12045600" cy="5598000"/>
           </a:xfrm>
           <a:prstGeom prst="rect">
             <a:avLst/>
@@ -9930,8 +9930,8 @@
         </p:nvSpPr>
         <p:spPr>
           <a:xfrm>
-            <a:off x="0" y="6372000"/>
-            <a:ext cx="12189600" cy="486000"/>
+            <a:off x="0" y="6364800"/>
+            <a:ext cx="12189600" cy="493200"/>
           </a:xfrm>
           <a:prstGeom prst="rect">
             <a:avLst/>
@@ -9975,8 +9975,8 @@
         </p:nvSpPr>
         <p:spPr>
           <a:xfrm>
-            <a:off x="180000" y="6390000"/>
-            <a:ext cx="11700000" cy="450000"/>
+            <a:off x="144000" y="6382800"/>
+            <a:ext cx="11880000" cy="457200"/>
           </a:xfrm>
           <a:prstGeom prst="rect">
             <a:avLst/>
@@ -9991,12 +9991,12 @@
           <a:p>
             <a:pPr algn="l"/>
             <a:r>
-              <a:rPr sz="1000" b="1" i="0">
+              <a:rPr sz="950" b="1" i="0">
                 <a:solidFill>
                   <a:srgbClr val="FF8C42"/>
                 </a:solidFill>
               </a:rPr>
-              <a:t>ВЫВОД: Банки температурно симметричны. Макс. ЕГТ: 101°C — в норме.</a:t>
+              <a:t>ВЫВОД: Банки симметричны.  |  Разброс: А=0°C  В=43°C.  |  Цил.2 горячее avg на +38°C</a:t>
             </a:r>
           </a:p>
         </p:txBody>
@@ -10199,7 +10199,7 @@
         <p:spPr>
           <a:xfrm>
             <a:off x="180000" y="36000"/>
-            <a:ext cx="11520000" cy="396000"/>
+            <a:ext cx="11520000" cy="360000"/>
           </a:xfrm>
           <a:prstGeom prst="rect">
             <a:avLst/>
@@ -10214,7 +10214,7 @@
           <a:p>
             <a:pPr algn="l"/>
             <a:r>
-              <a:rPr sz="1600" b="1" i="0">
+              <a:rPr sz="1500" b="1" i="0">
                 <a:solidFill>
                   <a:srgbClr val="FFFFFF"/>
                 </a:solidFill>
@@ -10232,8 +10232,8 @@
         </p:nvSpPr>
         <p:spPr>
           <a:xfrm>
-            <a:off x="180000" y="432000"/>
-            <a:ext cx="11520000" cy="234000"/>
+            <a:off x="180000" y="413999"/>
+            <a:ext cx="11520000" cy="251999"/>
           </a:xfrm>
           <a:prstGeom prst="rect">
             <a:avLst/>
@@ -10248,19 +10248,19 @@
           <a:p>
             <a:pPr algn="l"/>
             <a:r>
-              <a:rPr sz="950" b="0" i="0">
+              <a:rPr sz="900" b="0" i="0">
                 <a:solidFill>
                   <a:srgbClr val="667788"/>
                 </a:solidFill>
               </a:rPr>
-              <a:t>А-банк (нечётные, ECM144) — В-банк (чётные, ECM1)  |  Индивидуальные ЕГТ по цилиндрам</a:t>
+              <a:t>Δ внутри банков  |  Δ каждого цилиндра от среднего  |  Межбанковая асимметрия по времени</a:t>
             </a:r>
           </a:p>
         </p:txBody>
       </p:sp>
       <p:pic>
         <p:nvPicPr>
-          <p:cNvPr id="6" name="Picture 5" descr="tmppy02lg9k.png"/>
+          <p:cNvPr id="6" name="Picture 5" descr="tmpok7dp5vn.png"/>
           <p:cNvPicPr>
             <a:picLocks noChangeAspect="1"/>
           </p:cNvPicPr>
@@ -10274,8 +10274,8 @@
         </p:blipFill>
         <p:spPr>
           <a:xfrm>
-            <a:off x="108000" y="756000"/>
-            <a:ext cx="11952000" cy="5580000"/>
+            <a:off x="72000" y="737999"/>
+            <a:ext cx="12045600" cy="5598000"/>
           </a:xfrm>
           <a:prstGeom prst="rect">
             <a:avLst/>
@@ -10290,8 +10290,8 @@
         </p:nvSpPr>
         <p:spPr>
           <a:xfrm>
-            <a:off x="0" y="6372000"/>
-            <a:ext cx="12189600" cy="486000"/>
+            <a:off x="0" y="6364800"/>
+            <a:ext cx="12189600" cy="493200"/>
           </a:xfrm>
           <a:prstGeom prst="rect">
             <a:avLst/>
@@ -10335,8 +10335,8 @@
         </p:nvSpPr>
         <p:spPr>
           <a:xfrm>
-            <a:off x="180000" y="6390000"/>
-            <a:ext cx="11700000" cy="450000"/>
+            <a:off x="144000" y="6382800"/>
+            <a:ext cx="11880000" cy="457200"/>
           </a:xfrm>
           <a:prstGeom prst="rect">
             <a:avLst/>
@@ -10351,12 +10351,12 @@
           <a:p>
             <a:pPr algn="l"/>
             <a:r>
-              <a:rPr sz="1000" b="1" i="0">
+              <a:rPr sz="950" b="1" i="0">
                 <a:solidFill>
                   <a:srgbClr val="FF8C42"/>
                 </a:solidFill>
               </a:rPr>
-              <a:t>ВЫВОД: Банки температурно симметричны. Макс. ЕГТ: 102°C — в норме.</a:t>
+              <a:t>ВЫВОД: Банки симметричны.  |  Разброс: А=0°C  В=44°C.  |  Цил.2 горячее avg на +38°C</a:t>
             </a:r>
           </a:p>
         </p:txBody>
@@ -10559,7 +10559,7 @@
         <p:spPr>
           <a:xfrm>
             <a:off x="180000" y="36000"/>
-            <a:ext cx="11520000" cy="396000"/>
+            <a:ext cx="11520000" cy="360000"/>
           </a:xfrm>
           <a:prstGeom prst="rect">
             <a:avLst/>
@@ -10574,7 +10574,7 @@
           <a:p>
             <a:pPr algn="l"/>
             <a:r>
-              <a:rPr sz="1600" b="1" i="0">
+              <a:rPr sz="1500" b="1" i="0">
                 <a:solidFill>
                   <a:srgbClr val="FFFFFF"/>
                 </a:solidFill>
@@ -10592,8 +10592,8 @@
         </p:nvSpPr>
         <p:spPr>
           <a:xfrm>
-            <a:off x="180000" y="432000"/>
-            <a:ext cx="11520000" cy="234000"/>
+            <a:off x="180000" y="413999"/>
+            <a:ext cx="11520000" cy="251999"/>
           </a:xfrm>
           <a:prstGeom prst="rect">
             <a:avLst/>
@@ -10608,19 +10608,19 @@
           <a:p>
             <a:pPr algn="l"/>
             <a:r>
-              <a:rPr sz="950" b="0" i="0">
+              <a:rPr sz="900" b="0" i="0">
                 <a:solidFill>
                   <a:srgbClr val="667788"/>
                 </a:solidFill>
               </a:rPr>
-              <a:t>А-банк (нечётные, ECM144) — В-банк (чётные, ECM1)  |  Индивидуальные ЕГТ по цилиндрам</a:t>
+              <a:t>Δ внутри банков  |  Δ каждого цилиндра от среднего  |  Межбанковая асимметрия по времени</a:t>
             </a:r>
           </a:p>
         </p:txBody>
       </p:sp>
       <p:pic>
         <p:nvPicPr>
-          <p:cNvPr id="6" name="Picture 5" descr="tmpfnrp8z4k.png"/>
+          <p:cNvPr id="6" name="Picture 5" descr="tmp_38x6a9u.png"/>
           <p:cNvPicPr>
             <a:picLocks noChangeAspect="1"/>
           </p:cNvPicPr>
@@ -10634,8 +10634,8 @@
         </p:blipFill>
         <p:spPr>
           <a:xfrm>
-            <a:off x="108000" y="756000"/>
-            <a:ext cx="11952000" cy="5580000"/>
+            <a:off x="72000" y="737999"/>
+            <a:ext cx="12045600" cy="5598000"/>
           </a:xfrm>
           <a:prstGeom prst="rect">
             <a:avLst/>
@@ -10650,8 +10650,8 @@
         </p:nvSpPr>
         <p:spPr>
           <a:xfrm>
-            <a:off x="0" y="6372000"/>
-            <a:ext cx="12189600" cy="486000"/>
+            <a:off x="0" y="6364800"/>
+            <a:ext cx="12189600" cy="493200"/>
           </a:xfrm>
           <a:prstGeom prst="rect">
             <a:avLst/>
@@ -10695,8 +10695,8 @@
         </p:nvSpPr>
         <p:spPr>
           <a:xfrm>
-            <a:off x="180000" y="6390000"/>
-            <a:ext cx="11700000" cy="450000"/>
+            <a:off x="144000" y="6382800"/>
+            <a:ext cx="11880000" cy="457200"/>
           </a:xfrm>
           <a:prstGeom prst="rect">
             <a:avLst/>
@@ -10711,12 +10711,12 @@
           <a:p>
             <a:pPr algn="l"/>
             <a:r>
-              <a:rPr sz="1000" b="1" i="0">
+              <a:rPr sz="950" b="1" i="0">
                 <a:solidFill>
                   <a:srgbClr val="FF8C42"/>
                 </a:solidFill>
               </a:rPr>
-              <a:t>ВЫВОД: Банки температурно симметричны. Макс. ЕГТ: 558°C — КРИТИЧНО (&gt;500°C).</a:t>
+              <a:t>ВЫВОД: Банки симметричны.  |  Разброс: А=443°C  В=431°C.  |  Цил.15 горячее avg на +35°C</a:t>
             </a:r>
           </a:p>
         </p:txBody>
@@ -10919,7 +10919,7 @@
         <p:spPr>
           <a:xfrm>
             <a:off x="180000" y="36000"/>
-            <a:ext cx="11520000" cy="396000"/>
+            <a:ext cx="11520000" cy="360000"/>
           </a:xfrm>
           <a:prstGeom prst="rect">
             <a:avLst/>
@@ -10934,7 +10934,7 @@
           <a:p>
             <a:pPr algn="l"/>
             <a:r>
-              <a:rPr sz="1600" b="1" i="0">
+              <a:rPr sz="1500" b="1" i="0">
                 <a:solidFill>
                   <a:srgbClr val="FFFFFF"/>
                 </a:solidFill>
@@ -10952,8 +10952,8 @@
         </p:nvSpPr>
         <p:spPr>
           <a:xfrm>
-            <a:off x="180000" y="432000"/>
-            <a:ext cx="11520000" cy="234000"/>
+            <a:off x="180000" y="413999"/>
+            <a:ext cx="11520000" cy="251999"/>
           </a:xfrm>
           <a:prstGeom prst="rect">
             <a:avLst/>
@@ -10968,19 +10968,19 @@
           <a:p>
             <a:pPr algn="l"/>
             <a:r>
-              <a:rPr sz="950" b="0" i="0">
+              <a:rPr sz="900" b="0" i="0">
                 <a:solidFill>
                   <a:srgbClr val="667788"/>
                 </a:solidFill>
               </a:rPr>
-              <a:t>А-банк (нечётные, ECM144) — В-банк (чётные, ECM1)  |  Индивидуальные ЕГТ по цилиндрам</a:t>
+              <a:t>Δ внутри банков  |  Δ каждого цилиндра от среднего  |  Межбанковая асимметрия по времени</a:t>
             </a:r>
           </a:p>
         </p:txBody>
       </p:sp>
       <p:pic>
         <p:nvPicPr>
-          <p:cNvPr id="6" name="Picture 5" descr="tmpg2ga8vag.png"/>
+          <p:cNvPr id="6" name="Picture 5" descr="tmp23du8fen.png"/>
           <p:cNvPicPr>
             <a:picLocks noChangeAspect="1"/>
           </p:cNvPicPr>
@@ -10994,8 +10994,8 @@
         </p:blipFill>
         <p:spPr>
           <a:xfrm>
-            <a:off x="108000" y="756000"/>
-            <a:ext cx="11952000" cy="5580000"/>
+            <a:off x="72000" y="737999"/>
+            <a:ext cx="12045600" cy="5598000"/>
           </a:xfrm>
           <a:prstGeom prst="rect">
             <a:avLst/>
@@ -11010,8 +11010,8 @@
         </p:nvSpPr>
         <p:spPr>
           <a:xfrm>
-            <a:off x="0" y="6372000"/>
-            <a:ext cx="12189600" cy="486000"/>
+            <a:off x="0" y="6364800"/>
+            <a:ext cx="12189600" cy="493200"/>
           </a:xfrm>
           <a:prstGeom prst="rect">
             <a:avLst/>
@@ -11055,8 +11055,8 @@
         </p:nvSpPr>
         <p:spPr>
           <a:xfrm>
-            <a:off x="180000" y="6390000"/>
-            <a:ext cx="11700000" cy="450000"/>
+            <a:off x="144000" y="6382800"/>
+            <a:ext cx="11880000" cy="457200"/>
           </a:xfrm>
           <a:prstGeom prst="rect">
             <a:avLst/>
@@ -11071,12 +11071,12 @@
           <a:p>
             <a:pPr algn="l"/>
             <a:r>
-              <a:rPr sz="1000" b="1" i="0">
+              <a:rPr sz="950" b="1" i="0">
                 <a:solidFill>
                   <a:srgbClr val="FF8C42"/>
                 </a:solidFill>
               </a:rPr>
-              <a:t>ВЫВОД: Банки температурно симметричны. Макс. ЕГТ: 548°C — КРИТИЧНО (&gt;500°C).</a:t>
+              <a:t>ВЫВОД: Банки симметричны.  |  Разброс: А=404°C  В=391°C.  |  Цил.16 горячее avg на +21°C</a:t>
             </a:r>
           </a:p>
         </p:txBody>
@@ -16918,7 +16918,7 @@
         <p:spPr>
           <a:xfrm>
             <a:off x="180000" y="36000"/>
-            <a:ext cx="11520000" cy="396000"/>
+            <a:ext cx="11520000" cy="360000"/>
           </a:xfrm>
           <a:prstGeom prst="rect">
             <a:avLst/>
@@ -16933,7 +16933,7 @@
           <a:p>
             <a:pPr algn="l"/>
             <a:r>
-              <a:rPr sz="1600" b="1" i="0">
+              <a:rPr sz="1500" b="1" i="0">
                 <a:solidFill>
                   <a:srgbClr val="FFFFFF"/>
                 </a:solidFill>
@@ -16951,8 +16951,8 @@
         </p:nvSpPr>
         <p:spPr>
           <a:xfrm>
-            <a:off x="180000" y="432000"/>
-            <a:ext cx="11520000" cy="234000"/>
+            <a:off x="180000" y="413999"/>
+            <a:ext cx="11520000" cy="251999"/>
           </a:xfrm>
           <a:prstGeom prst="rect">
             <a:avLst/>
@@ -16967,19 +16967,19 @@
           <a:p>
             <a:pPr algn="l"/>
             <a:r>
-              <a:rPr sz="950" b="0" i="0">
+              <a:rPr sz="900" b="0" i="0">
                 <a:solidFill>
                   <a:srgbClr val="667788"/>
                 </a:solidFill>
               </a:rPr>
-              <a:t>А-банк (нечётные, ECM144) — В-банк (чётные, ECM1)  |  Индивидуальные ЕГТ по цилиндрам</a:t>
+              <a:t>Δ внутри банков  |  Δ каждого цилиндра от среднего  |  Межбанковая асимметрия по времени</a:t>
             </a:r>
           </a:p>
         </p:txBody>
       </p:sp>
       <p:pic>
         <p:nvPicPr>
-          <p:cNvPr id="6" name="Picture 5" descr="tmpg12y87hn.png"/>
+          <p:cNvPr id="6" name="Picture 5" descr="tmpzvncarjh.png"/>
           <p:cNvPicPr>
             <a:picLocks noChangeAspect="1"/>
           </p:cNvPicPr>
@@ -16993,8 +16993,8 @@
         </p:blipFill>
         <p:spPr>
           <a:xfrm>
-            <a:off x="108000" y="756000"/>
-            <a:ext cx="11952000" cy="5580000"/>
+            <a:off x="72000" y="737999"/>
+            <a:ext cx="12045600" cy="5598000"/>
           </a:xfrm>
           <a:prstGeom prst="rect">
             <a:avLst/>
@@ -17009,8 +17009,8 @@
         </p:nvSpPr>
         <p:spPr>
           <a:xfrm>
-            <a:off x="0" y="6372000"/>
-            <a:ext cx="12189600" cy="486000"/>
+            <a:off x="0" y="6364800"/>
+            <a:ext cx="12189600" cy="493200"/>
           </a:xfrm>
           <a:prstGeom prst="rect">
             <a:avLst/>
@@ -17054,8 +17054,8 @@
         </p:nvSpPr>
         <p:spPr>
           <a:xfrm>
-            <a:off x="180000" y="6390000"/>
-            <a:ext cx="11700000" cy="450000"/>
+            <a:off x="144000" y="6382800"/>
+            <a:ext cx="11880000" cy="457200"/>
           </a:xfrm>
           <a:prstGeom prst="rect">
             <a:avLst/>
@@ -17070,12 +17070,12 @@
           <a:p>
             <a:pPr algn="l"/>
             <a:r>
-              <a:rPr sz="1000" b="1" i="0">
+              <a:rPr sz="950" b="1" i="0">
                 <a:solidFill>
                   <a:srgbClr val="FF8C42"/>
                 </a:solidFill>
               </a:rPr>
-              <a:t>ВЫВОД: А-банк горячее В-банка на 44°C. Макс. ЕГТ: 745°C — КРИТИЧНО (&gt;500°C).</a:t>
+              <a:t>ВЫВОД: А-банк горячее В-банка на 44°C.  |  Разброс: А=498°C  В=95°C.  |  Цил.15 горячее avg на +219°C</a:t>
             </a:r>
           </a:p>
         </p:txBody>
@@ -17278,7 +17278,7 @@
         <p:spPr>
           <a:xfrm>
             <a:off x="180000" y="36000"/>
-            <a:ext cx="11520000" cy="396000"/>
+            <a:ext cx="11520000" cy="360000"/>
           </a:xfrm>
           <a:prstGeom prst="rect">
             <a:avLst/>
@@ -17293,7 +17293,7 @@
           <a:p>
             <a:pPr algn="l"/>
             <a:r>
-              <a:rPr sz="1600" b="1" i="0">
+              <a:rPr sz="1500" b="1" i="0">
                 <a:solidFill>
                   <a:srgbClr val="FFFFFF"/>
                 </a:solidFill>
@@ -17311,8 +17311,8 @@
         </p:nvSpPr>
         <p:spPr>
           <a:xfrm>
-            <a:off x="180000" y="432000"/>
-            <a:ext cx="11520000" cy="234000"/>
+            <a:off x="180000" y="413999"/>
+            <a:ext cx="11520000" cy="251999"/>
           </a:xfrm>
           <a:prstGeom prst="rect">
             <a:avLst/>
@@ -17327,19 +17327,19 @@
           <a:p>
             <a:pPr algn="l"/>
             <a:r>
-              <a:rPr sz="950" b="0" i="0">
+              <a:rPr sz="900" b="0" i="0">
                 <a:solidFill>
                   <a:srgbClr val="667788"/>
                 </a:solidFill>
               </a:rPr>
-              <a:t>А-банк (нечётные, ECM144) — В-банк (чётные, ECM1)  |  Индивидуальные ЕГТ по цилиндрам</a:t>
+              <a:t>Δ внутри банков  |  Δ каждого цилиндра от среднего  |  Межбанковая асимметрия по времени</a:t>
             </a:r>
           </a:p>
         </p:txBody>
       </p:sp>
       <p:pic>
         <p:nvPicPr>
-          <p:cNvPr id="6" name="Picture 5" descr="tmpavivo3ar.png"/>
+          <p:cNvPr id="6" name="Picture 5" descr="tmp4b373641.png"/>
           <p:cNvPicPr>
             <a:picLocks noChangeAspect="1"/>
           </p:cNvPicPr>
@@ -17353,8 +17353,8 @@
         </p:blipFill>
         <p:spPr>
           <a:xfrm>
-            <a:off x="108000" y="756000"/>
-            <a:ext cx="11952000" cy="5580000"/>
+            <a:off x="72000" y="737999"/>
+            <a:ext cx="12045600" cy="5598000"/>
           </a:xfrm>
           <a:prstGeom prst="rect">
             <a:avLst/>
@@ -17369,8 +17369,8 @@
         </p:nvSpPr>
         <p:spPr>
           <a:xfrm>
-            <a:off x="0" y="6372000"/>
-            <a:ext cx="12189600" cy="486000"/>
+            <a:off x="0" y="6364800"/>
+            <a:ext cx="12189600" cy="493200"/>
           </a:xfrm>
           <a:prstGeom prst="rect">
             <a:avLst/>
@@ -17414,8 +17414,8 @@
         </p:nvSpPr>
         <p:spPr>
           <a:xfrm>
-            <a:off x="180000" y="6390000"/>
-            <a:ext cx="11700000" cy="450000"/>
+            <a:off x="144000" y="6382800"/>
+            <a:ext cx="11880000" cy="457200"/>
           </a:xfrm>
           <a:prstGeom prst="rect">
             <a:avLst/>
@@ -17430,12 +17430,12 @@
           <a:p>
             <a:pPr algn="l"/>
             <a:r>
-              <a:rPr sz="1000" b="1" i="0">
+              <a:rPr sz="950" b="1" i="0">
                 <a:solidFill>
                   <a:srgbClr val="FF8C42"/>
                 </a:solidFill>
               </a:rPr>
-              <a:t>ВЫВОД: А-банк горячее В-банка на 13°C. Макс. ЕГТ: 460°C — ВНИМАНИЕ (&gt;450°C).</a:t>
+              <a:t>ВЫВОД: А-банк горячее В-банка на 13°C.  |  Разброс: А=202°C  В=171°C.  |  Цил.13 горячее avg на +14°C</a:t>
             </a:r>
           </a:p>
         </p:txBody>
@@ -17638,7 +17638,7 @@
         <p:spPr>
           <a:xfrm>
             <a:off x="180000" y="36000"/>
-            <a:ext cx="11520000" cy="396000"/>
+            <a:ext cx="11520000" cy="360000"/>
           </a:xfrm>
           <a:prstGeom prst="rect">
             <a:avLst/>
@@ -17653,7 +17653,7 @@
           <a:p>
             <a:pPr algn="l"/>
             <a:r>
-              <a:rPr sz="1600" b="1" i="0">
+              <a:rPr sz="1500" b="1" i="0">
                 <a:solidFill>
                   <a:srgbClr val="FFFFFF"/>
                 </a:solidFill>
@@ -17671,8 +17671,8 @@
         </p:nvSpPr>
         <p:spPr>
           <a:xfrm>
-            <a:off x="180000" y="432000"/>
-            <a:ext cx="11520000" cy="234000"/>
+            <a:off x="180000" y="413999"/>
+            <a:ext cx="11520000" cy="251999"/>
           </a:xfrm>
           <a:prstGeom prst="rect">
             <a:avLst/>
@@ -17687,19 +17687,19 @@
           <a:p>
             <a:pPr algn="l"/>
             <a:r>
-              <a:rPr sz="950" b="0" i="0">
+              <a:rPr sz="900" b="0" i="0">
                 <a:solidFill>
                   <a:srgbClr val="667788"/>
                 </a:solidFill>
               </a:rPr>
-              <a:t>А-банк (нечётные, ECM144) — В-банк (чётные, ECM1)  |  Индивидуальные ЕГТ по цилиндрам</a:t>
+              <a:t>Δ внутри банков  |  Δ каждого цилиндра от среднего  |  Межбанковая асимметрия по времени</a:t>
             </a:r>
           </a:p>
         </p:txBody>
       </p:sp>
       <p:pic>
         <p:nvPicPr>
-          <p:cNvPr id="6" name="Picture 5" descr="tmpapdzr987.png"/>
+          <p:cNvPr id="6" name="Picture 5" descr="tmpjcdlgyae.png"/>
           <p:cNvPicPr>
             <a:picLocks noChangeAspect="1"/>
           </p:cNvPicPr>
@@ -17713,8 +17713,8 @@
         </p:blipFill>
         <p:spPr>
           <a:xfrm>
-            <a:off x="108000" y="756000"/>
-            <a:ext cx="11952000" cy="5580000"/>
+            <a:off x="72000" y="737999"/>
+            <a:ext cx="12045600" cy="5598000"/>
           </a:xfrm>
           <a:prstGeom prst="rect">
             <a:avLst/>
@@ -17729,8 +17729,8 @@
         </p:nvSpPr>
         <p:spPr>
           <a:xfrm>
-            <a:off x="0" y="6372000"/>
-            <a:ext cx="12189600" cy="486000"/>
+            <a:off x="0" y="6364800"/>
+            <a:ext cx="12189600" cy="493200"/>
           </a:xfrm>
           <a:prstGeom prst="rect">
             <a:avLst/>
@@ -17774,8 +17774,8 @@
         </p:nvSpPr>
         <p:spPr>
           <a:xfrm>
-            <a:off x="180000" y="6390000"/>
-            <a:ext cx="11700000" cy="450000"/>
+            <a:off x="144000" y="6382800"/>
+            <a:ext cx="11880000" cy="457200"/>
           </a:xfrm>
           <a:prstGeom prst="rect">
             <a:avLst/>
@@ -17790,12 +17790,12 @@
           <a:p>
             <a:pPr algn="l"/>
             <a:r>
-              <a:rPr sz="1000" b="1" i="0">
+              <a:rPr sz="950" b="1" i="0">
                 <a:solidFill>
                   <a:srgbClr val="FF8C42"/>
                 </a:solidFill>
               </a:rPr>
-              <a:t>ВЫВОД: Банки температурно симметричны. Макс. ЕГТ: 108°C — в норме.</a:t>
+              <a:t>ВЫВОД: Банки симметричны.  |  Разброс: А=44°C  В=50°C.  |  Цил.6 горячее avg на +40°C</a:t>
             </a:r>
           </a:p>
         </p:txBody>
@@ -18059,7 +18059,7 @@
       </p:sp>
       <p:pic>
         <p:nvPicPr>
-          <p:cNvPr id="6" name="Picture 5" descr="tmpg4l0iogl.png"/>
+          <p:cNvPr id="6" name="Picture 5" descr="tmpg0yjigjv.png"/>
           <p:cNvPicPr>
             <a:picLocks noChangeAspect="1"/>
           </p:cNvPicPr>
@@ -18340,7 +18340,7 @@
       </p:sp>
       <p:pic>
         <p:nvPicPr>
-          <p:cNvPr id="6" name="Picture 5" descr="tmpmc4zwgj9.png"/>
+          <p:cNvPr id="6" name="Picture 5" descr="tmpr902x0r0.png"/>
           <p:cNvPicPr>
             <a:picLocks noChangeAspect="1"/>
           </p:cNvPicPr>
@@ -18621,7 +18621,7 @@
       </p:sp>
       <p:pic>
         <p:nvPicPr>
-          <p:cNvPr id="6" name="Picture 5" descr="tmph63082xx.png"/>
+          <p:cNvPr id="6" name="Picture 5" descr="tmpuv077046.png"/>
           <p:cNvPicPr>
             <a:picLocks noChangeAspect="1"/>
           </p:cNvPicPr>
@@ -18981,7 +18981,7 @@
       </p:sp>
       <p:pic>
         <p:nvPicPr>
-          <p:cNvPr id="6" name="Picture 5" descr="tmptaxgiv2x.png"/>
+          <p:cNvPr id="6" name="Picture 5" descr="tmpaasuhg95.png"/>
           <p:cNvPicPr>
             <a:picLocks noChangeAspect="1"/>
           </p:cNvPicPr>
@@ -19341,7 +19341,7 @@
       </p:sp>
       <p:pic>
         <p:nvPicPr>
-          <p:cNvPr id="6" name="Picture 5" descr="tmp7txq4uk_.png"/>
+          <p:cNvPr id="6" name="Picture 5" descr="tmpklr586ug.png"/>
           <p:cNvPicPr>
             <a:picLocks noChangeAspect="1"/>
           </p:cNvPicPr>
@@ -19701,7 +19701,7 @@
       </p:sp>
       <p:pic>
         <p:nvPicPr>
-          <p:cNvPr id="6" name="Picture 5" descr="tmpgodkomev.png"/>
+          <p:cNvPr id="6" name="Picture 5" descr="tmpho42i1kw.png"/>
           <p:cNvPicPr>
             <a:picLocks noChangeAspect="1"/>
           </p:cNvPicPr>
@@ -20061,7 +20061,7 @@
       </p:sp>
       <p:pic>
         <p:nvPicPr>
-          <p:cNvPr id="6" name="Picture 5" descr="tmprj__rq8y.png"/>
+          <p:cNvPr id="6" name="Picture 5" descr="tmpqvzfso6i.png"/>
           <p:cNvPicPr>
             <a:picLocks noChangeAspect="1"/>
           </p:cNvPicPr>

</xml_diff>